<commit_message>
feat: add prepared offline knowledge base
</commit_message>
<xml_diff>
--- a/deliverables/CMS-RAG_Nihai_Proje_Sunumu.pptx
+++ b/deliverables/CMS-RAG_Nihai_Proje_Sunumu.pptx
@@ -3487,7 +3487,7 @@
                 </a:solidFill>
                 <a:latin typeface="Aptos"/>
               </a:rPr>
-              <a:t>WEB</a:t>
+              <a:t>SNAPSHOT</a:t>
             </a:r>
           </a:p>
         </p:txBody>
@@ -3906,7 +3906,7 @@
                 </a:solidFill>
                 <a:latin typeface="Aptos"/>
               </a:rPr>
-              <a:t>Sürüm 1.0  ·  26.07.2026  ·  develop@d022506</a:t>
+              <a:t>Sürüm 1.1  ·  30.07.2026  ·  codex/offline-knowledge-base</a:t>
             </a:r>
           </a:p>
         </p:txBody>
@@ -12834,7 +12834,7 @@
                 </a:solidFill>
                 <a:latin typeface="Aptos"/>
               </a:rPr>
-              <a:t>33/33 + 4/4</a:t>
+              <a:t>38/38 + 8/8</a:t>
             </a:r>
           </a:p>
         </p:txBody>
@@ -12939,7 +12939,7 @@
                 </a:solidFill>
                 <a:latin typeface="Aptos"/>
               </a:rPr>
-              <a:t>develop@d022506  ·  Sürüm 1.0</a:t>
+              <a:t>codex/offline-knowledge-base  ·  Sürüm 1.1</a:t>
             </a:r>
           </a:p>
         </p:txBody>
@@ -13148,7 +13148,7 @@
                 </a:solidFill>
                 <a:latin typeface="Aptos"/>
               </a:rPr>
-              <a:t>Dağınık teknik dokümanı denetlenebilir, yerel ve kaynaklı cevaba dönüştürür.</a:t>
+              <a:t>Önceden hazırlanmış kamu bilgisini çevrimdışı, yerel ve kaynaklı cevaba dönüştürür.</a:t>
             </a:r>
           </a:p>
         </p:txBody>
@@ -13271,7 +13271,7 @@
                 </a:solidFill>
                 <a:latin typeface="Aptos"/>
               </a:rPr>
-              <a:t>33 / 33</a:t>
+              <a:t>38 / 38</a:t>
             </a:r>
           </a:p>
         </p:txBody>
@@ -13429,7 +13429,7 @@
                 </a:solidFill>
                 <a:latin typeface="Aptos"/>
               </a:rPr>
-              <a:t>4 / 4</a:t>
+              <a:t>8 / 8</a:t>
             </a:r>
           </a:p>
         </p:txBody>
@@ -13587,7 +13587,7 @@
                 </a:solidFill>
                 <a:latin typeface="Aptos"/>
               </a:rPr>
-              <a:t>59</a:t>
+              <a:t>75</a:t>
             </a:r>
           </a:p>
         </p:txBody>
@@ -13943,8 +13943,8 @@
         </p:nvSpPr>
         <p:spPr>
           <a:xfrm>
-            <a:off x="8686800" y="3749039"/>
-            <a:ext cx="1920240" cy="310896"/>
+            <a:off x="8458200" y="3749039"/>
+            <a:ext cx="2377440" cy="310896"/>
           </a:xfrm>
           <a:prstGeom prst="roundRect">
             <a:avLst/>
@@ -13988,8 +13988,8 @@
         </p:nvSpPr>
         <p:spPr>
           <a:xfrm>
-            <a:off x="8759952" y="3813048"/>
-            <a:ext cx="1773936" cy="164592"/>
+            <a:off x="8531352" y="3813048"/>
+            <a:ext cx="2231136" cy="164592"/>
           </a:xfrm>
           <a:prstGeom prst="rect">
             <a:avLst/>
@@ -14010,7 +14010,7 @@
                 </a:solidFill>
                 <a:latin typeface="Aptos"/>
               </a:rPr>
-              <a:t>YEREL OLLAMA</a:t>
+              <a:t>ÇEVRIMDIŞI ÇALIŞMA</a:t>
             </a:r>
           </a:p>
         </p:txBody>
@@ -14023,8 +14023,8 @@
         </p:nvSpPr>
         <p:spPr>
           <a:xfrm>
-            <a:off x="8458200" y="4343400"/>
-            <a:ext cx="2377440" cy="310896"/>
+            <a:off x="8686800" y="4343400"/>
+            <a:ext cx="1920240" cy="310896"/>
           </a:xfrm>
           <a:prstGeom prst="roundRect">
             <a:avLst/>
@@ -14068,8 +14068,8 @@
         </p:nvSpPr>
         <p:spPr>
           <a:xfrm>
-            <a:off x="8531352" y="4407408"/>
-            <a:ext cx="2231136" cy="164592"/>
+            <a:off x="8759952" y="4407408"/>
+            <a:ext cx="1773936" cy="164592"/>
           </a:xfrm>
           <a:prstGeom prst="rect">
             <a:avLst/>
@@ -14090,7 +14090,7 @@
                 </a:solidFill>
                 <a:latin typeface="Aptos"/>
               </a:rPr>
-              <a:t>KOLEKSIYON IZOLASYONU</a:t>
+              <a:t>HAZIR SNAPSHOT</a:t>
             </a:r>
           </a:p>
         </p:txBody>
@@ -16766,7 +16766,7 @@
                 </a:solidFill>
                 <a:latin typeface="Aptos Display"/>
               </a:rPr>
-              <a:t>PDF, yüklemeden kanıta kadar izlenebilir</a:t>
+              <a:t>Araştırmadan hazır yerel kanıta kadar izlenebilir</a:t>
             </a:r>
           </a:p>
         </p:txBody>
@@ -16881,7 +16881,7 @@
                 </a:solidFill>
                 <a:latin typeface="Aptos"/>
               </a:rPr>
-              <a:t>Doğrula</a:t>
+              <a:t>Araştır</a:t>
             </a:r>
           </a:p>
         </p:txBody>
@@ -16916,7 +16916,7 @@
                 </a:solidFill>
                 <a:latin typeface="Aptos"/>
               </a:rPr>
-              <a:t>%PDF + 200 MB</a:t>
+              <a:t>Birincil kamu kaynağı</a:t>
             </a:r>
           </a:p>
         </p:txBody>
@@ -17066,7 +17066,7 @@
                 </a:solidFill>
                 <a:latin typeface="Aptos"/>
               </a:rPr>
-              <a:t>Kimlik</a:t>
+              <a:t>Kürasyon</a:t>
             </a:r>
           </a:p>
         </p:txBody>
@@ -17101,7 +17101,7 @@
                 </a:solidFill>
                 <a:latin typeface="Aptos"/>
               </a:rPr>
-              <a:t>SHA-256</a:t>
+              <a:t>Kapsam + kaynak</a:t>
             </a:r>
           </a:p>
         </p:txBody>
@@ -17251,7 +17251,7 @@
                 </a:solidFill>
                 <a:latin typeface="Aptos"/>
               </a:rPr>
-              <a:t>Sakla</a:t>
+              <a:t>PDF</a:t>
             </a:r>
           </a:p>
         </p:txBody>
@@ -17286,7 +17286,7 @@
                 </a:solidFill>
                 <a:latin typeface="Aptos"/>
               </a:rPr>
-              <a:t>İçerik adresli</a:t>
+              <a:t>Metin çıkarılabilir</a:t>
             </a:r>
           </a:p>
         </p:txBody>
@@ -17436,7 +17436,7 @@
                 </a:solidFill>
                 <a:latin typeface="Aptos"/>
               </a:rPr>
-              <a:t>Manifest</a:t>
+              <a:t>Parçala</a:t>
             </a:r>
           </a:p>
         </p:txBody>
@@ -17471,7 +17471,7 @@
                 </a:solidFill>
                 <a:latin typeface="Aptos"/>
               </a:rPr>
-              <a:t>Ad + boyut + tarih</a:t>
+              <a:t>Sayfa + overlap</a:t>
             </a:r>
           </a:p>
         </p:txBody>
@@ -17621,7 +17621,7 @@
                 </a:solidFill>
                 <a:latin typeface="Aptos"/>
               </a:rPr>
-              <a:t>Parçala</a:t>
+              <a:t>Embedding</a:t>
             </a:r>
           </a:p>
         </p:txBody>
@@ -17656,7 +17656,7 @@
                 </a:solidFill>
                 <a:latin typeface="Aptos"/>
               </a:rPr>
-              <a:t>Sayfa + overlap</a:t>
+              <a:t>Önceden hesapla</a:t>
             </a:r>
           </a:p>
         </p:txBody>
@@ -17806,7 +17806,7 @@
                 </a:solidFill>
                 <a:latin typeface="Aptos"/>
               </a:rPr>
-              <a:t>İndeksle</a:t>
+              <a:t>Snapshot</a:t>
             </a:r>
           </a:p>
         </p:txBody>
@@ -17841,7 +17841,7 @@
                 </a:solidFill>
                 <a:latin typeface="Aptos"/>
               </a:rPr>
-              <a:t>FAISS + BM25</a:t>
+              <a:t>Manifest + vektör</a:t>
             </a:r>
           </a:p>
         </p:txBody>
@@ -17900,7 +17900,7 @@
         <p:spPr>
           <a:xfrm>
             <a:off x="960120" y="4517136"/>
-            <a:ext cx="1463040" cy="274320"/>
+            <a:ext cx="1645920" cy="274320"/>
           </a:xfrm>
           <a:prstGeom prst="rect">
             <a:avLst/>
@@ -17921,7 +17921,7 @@
                 </a:solidFill>
                 <a:latin typeface="Aptos"/>
               </a:rPr>
-              <a:t>Aynı içerik?</a:t>
+              <a:t>Normal kullanım</a:t>
             </a:r>
           </a:p>
         </p:txBody>
@@ -17934,8 +17934,8 @@
         </p:nvSpPr>
         <p:spPr>
           <a:xfrm>
-            <a:off x="2331720" y="4517136"/>
-            <a:ext cx="3246120" cy="365760"/>
+            <a:off x="2423160" y="4517136"/>
+            <a:ext cx="3154680" cy="365760"/>
           </a:xfrm>
           <a:prstGeom prst="rect">
             <a:avLst/>
@@ -17956,7 +17956,7 @@
                 </a:solidFill>
                 <a:latin typeface="Aptos"/>
               </a:rPr>
-              <a:t>İkinci kayıt yok · kullanıcıya duplicate bilgisi</a:t>
+              <a:t>Hazır snapshot yüklenir · web erişimi yok</a:t>
             </a:r>
           </a:p>
         </p:txBody>
@@ -18036,7 +18036,7 @@
                 </a:solidFill>
                 <a:latin typeface="Aptos"/>
               </a:rPr>
-              <a:t>Bozuk PDF?</a:t>
+              <a:t>Ek belge?</a:t>
             </a:r>
           </a:p>
         </p:txBody>
@@ -18071,7 +18071,7 @@
                 </a:solidFill>
                 <a:latin typeface="Aptos"/>
               </a:rPr>
-              <a:t>Dosya atlanır · tüm indeksleme durmaz</a:t>
+              <a:t>SHA-256 kontrolü · yalnız ek belge indekslenir</a:t>
             </a:r>
           </a:p>
         </p:txBody>

</xml_diff>

<commit_message>
fix: align evidence retrieval and answer decisions
</commit_message>
<xml_diff>
--- a/deliverables/CMS-RAG_Nihai_Proje_Sunumu.pptx
+++ b/deliverables/CMS-RAG_Nihai_Proje_Sunumu.pptx
@@ -12834,7 +12834,7 @@
                 </a:solidFill>
                 <a:latin typeface="Aptos"/>
               </a:rPr>
-              <a:t>38/38 + 8/8</a:t>
+              <a:t>41/41 + 8/8 + 7/7</a:t>
             </a:r>
           </a:p>
         </p:txBody>
@@ -13271,7 +13271,7 @@
                 </a:solidFill>
                 <a:latin typeface="Aptos"/>
               </a:rPr>
-              <a:t>38 / 38</a:t>
+              <a:t>41 / 41</a:t>
             </a:r>
           </a:p>
         </p:txBody>
@@ -13587,7 +13587,7 @@
                 </a:solidFill>
                 <a:latin typeface="Aptos"/>
               </a:rPr>
-              <a:t>75</a:t>
+              <a:t>67</a:t>
             </a:r>
           </a:p>
         </p:txBody>

</xml_diff>

<commit_message>
feat: expand evaluation and add privacy-safe audit
</commit_message>
<xml_diff>
--- a/deliverables/CMS-RAG_Nihai_Proje_Sunumu.pptx
+++ b/deliverables/CMS-RAG_Nihai_Proje_Sunumu.pptx
@@ -3906,7 +3906,7 @@
                 </a:solidFill>
                 <a:latin typeface="Aptos"/>
               </a:rPr>
-              <a:t>Sürüm 1.1  ·  30.07.2026  ·  codex/offline-knowledge-base</a:t>
+              <a:t>Sürüm 1.2  ·  02.08.2026  ·  codex/evaluation-benchmark</a:t>
             </a:r>
           </a:p>
         </p:txBody>
@@ -5194,7 +5194,7 @@
                 </a:solidFill>
                 <a:latin typeface="Aptos"/>
               </a:rPr>
-              <a:t>33 / 33</a:t>
+              <a:t>69 / 69</a:t>
             </a:r>
           </a:p>
         </p:txBody>
@@ -5229,7 +5229,7 @@
                 </a:solidFill>
                 <a:latin typeface="Aptos"/>
               </a:rPr>
-              <a:t>TEST</a:t>
+              <a:t>OTOMATİK TEST</a:t>
             </a:r>
           </a:p>
         </p:txBody>
@@ -5352,7 +5352,7 @@
                 </a:solidFill>
                 <a:latin typeface="Aptos"/>
               </a:rPr>
-              <a:t>4 / 4</a:t>
+              <a:t>45 / 45</a:t>
             </a:r>
           </a:p>
         </p:txBody>
@@ -5387,7 +5387,7 @@
                 </a:solidFill>
                 <a:latin typeface="Aptos"/>
               </a:rPr>
-              <a:t>RETRIEVAL</a:t>
+              <a:t>ALTIN SET</a:t>
             </a:r>
           </a:p>
         </p:txBody>
@@ -5510,7 +5510,7 @@
                 </a:solidFill>
                 <a:latin typeface="Aptos"/>
               </a:rPr>
-              <a:t>34 / 34</a:t>
+              <a:t>30 / 30</a:t>
             </a:r>
           </a:p>
         </p:txBody>
@@ -5545,7 +5545,7 @@
                 </a:solidFill>
                 <a:latin typeface="Aptos"/>
               </a:rPr>
-              <a:t>PDF SAYFASI</a:t>
+              <a:t>LLM HAKEM</a:t>
             </a:r>
           </a:p>
         </p:txBody>
@@ -5668,7 +5668,7 @@
                 </a:solidFill>
                 <a:latin typeface="Aptos"/>
               </a:rPr>
-              <a:t>0</a:t>
+              <a:t>0 / 0</a:t>
             </a:r>
           </a:p>
         </p:txBody>
@@ -5703,7 +5703,7 @@
                 </a:solidFill>
                 <a:latin typeface="Aptos"/>
               </a:rPr>
-              <a:t>EKSİK KAYNAK</a:t>
+              <a:t>FP / FN</a:t>
             </a:r>
           </a:p>
         </p:txBody>
@@ -5797,7 +5797,7 @@
         <p:spPr>
           <a:xfrm>
             <a:off x="2148840" y="3364991"/>
-            <a:ext cx="3474720" cy="164592"/>
+            <a:ext cx="2223820" cy="164592"/>
           </a:xfrm>
           <a:prstGeom prst="rect">
             <a:avLst/>
@@ -5863,7 +5863,7 @@
                 </a:solidFill>
                 <a:latin typeface="Aptos"/>
               </a:rPr>
-              <a:t>7</a:t>
+              <a:t>8</a:t>
             </a:r>
           </a:p>
         </p:txBody>
@@ -6023,7 +6023,7 @@
                 </a:solidFill>
                 <a:latin typeface="Aptos"/>
               </a:rPr>
-              <a:t>14</a:t>
+              <a:t>25</a:t>
             </a:r>
           </a:p>
         </p:txBody>
@@ -6058,7 +6058,7 @@
                 </a:solidFill>
                 <a:latin typeface="Aptos"/>
               </a:rPr>
-              <a:t>UI</a:t>
+              <a:t>UI + PDF</a:t>
             </a:r>
           </a:p>
         </p:txBody>
@@ -6117,7 +6117,7 @@
         <p:spPr>
           <a:xfrm>
             <a:off x="2148840" y="4370832"/>
-            <a:ext cx="1985554" cy="164592"/>
+            <a:ext cx="2223820" cy="164592"/>
           </a:xfrm>
           <a:prstGeom prst="rect">
             <a:avLst/>
@@ -6183,7 +6183,7 @@
                 </a:solidFill>
                 <a:latin typeface="Aptos"/>
               </a:rPr>
-              <a:t>4</a:t>
+              <a:t>8</a:t>
             </a:r>
           </a:p>
         </p:txBody>
@@ -6218,7 +6218,7 @@
                 </a:solidFill>
                 <a:latin typeface="Aptos"/>
               </a:rPr>
-              <a:t>Ingest</a:t>
+              <a:t>Eval + Audit</a:t>
             </a:r>
           </a:p>
         </p:txBody>
@@ -6277,7 +6277,7 @@
         <p:spPr>
           <a:xfrm>
             <a:off x="2148840" y="4873752"/>
-            <a:ext cx="1985554" cy="164592"/>
+            <a:ext cx="3057753" cy="164592"/>
           </a:xfrm>
           <a:prstGeom prst="rect">
             <a:avLst/>
@@ -6343,7 +6343,7 @@
                 </a:solidFill>
                 <a:latin typeface="Aptos"/>
               </a:rPr>
-              <a:t>4</a:t>
+              <a:t>11</a:t>
             </a:r>
           </a:p>
         </p:txBody>
@@ -6437,7 +6437,7 @@
         <p:spPr>
           <a:xfrm>
             <a:off x="2148840" y="5376672"/>
-            <a:ext cx="1489165" cy="164592"/>
+            <a:ext cx="833932" cy="164592"/>
           </a:xfrm>
           <a:prstGeom prst="rect">
             <a:avLst/>
@@ -7789,7 +7789,7 @@
                 </a:solidFill>
                 <a:latin typeface="Aptos"/>
               </a:rPr>
-              <a:t>Üretime geçişte: RBAC · disk şifreleme · audit · zararlı dosya taraması</a:t>
+              <a:t>Yerel audit hazır · Üretime geçişte: RBAC · merkezi aktarım · disk şifreleme</a:t>
             </a:r>
           </a:p>
         </p:txBody>
@@ -10457,7 +10457,7 @@
                 <a:latin typeface="Aptos"/>
               </a:rPr>
               <a:t>Kalıcı vektör deposu
-RAG kalite paneli
+Kalite eğilim alarmı
 RBAC</a:t>
             </a:r>
           </a:p>
@@ -10653,7 +10653,7 @@
                 </a:solidFill>
                 <a:latin typeface="Aptos"/>
               </a:rPr>
-              <a:t>Audit entegrasyonu
+              <a:t>Merkezi audit aktarımı
 Çok modlu retrieval
 Kaynak onay akışı</a:t>
             </a:r>
@@ -12834,7 +12834,7 @@
                 </a:solidFill>
                 <a:latin typeface="Aptos"/>
               </a:rPr>
-              <a:t>41/41 + 8/8 + 7/7</a:t>
+              <a:t>69/69 + 45/45 + 30/30</a:t>
             </a:r>
           </a:p>
         </p:txBody>
@@ -12939,7 +12939,7 @@
                 </a:solidFill>
                 <a:latin typeface="Aptos"/>
               </a:rPr>
-              <a:t>codex/offline-knowledge-base  ·  Sürüm 1.1</a:t>
+              <a:t>codex/evaluation-benchmark  ·  Sürüm 1.2</a:t>
             </a:r>
           </a:p>
         </p:txBody>

</xml_diff>

<commit_message>
feat: add chunk-lineage evaluation and expand knowledge base
</commit_message>
<xml_diff>
--- a/deliverables/CMS-RAG_Nihai_Proje_Sunumu.pptx
+++ b/deliverables/CMS-RAG_Nihai_Proje_Sunumu.pptx
@@ -3906,7 +3906,7 @@
                 </a:solidFill>
                 <a:latin typeface="Aptos"/>
               </a:rPr>
-              <a:t>Sürüm 1.2  ·  02.08.2026  ·  codex/evaluation-benchmark</a:t>
+              <a:t>Sürüm 1.3  ·  06.08.2026  ·  codex/evaluation-benchmark</a:t>
             </a:r>
           </a:p>
         </p:txBody>
@@ -5194,7 +5194,7 @@
                 </a:solidFill>
                 <a:latin typeface="Aptos"/>
               </a:rPr>
-              <a:t>69 / 69</a:t>
+              <a:t>82 / 82</a:t>
             </a:r>
           </a:p>
         </p:txBody>
@@ -5668,7 +5668,7 @@
                 </a:solidFill>
                 <a:latin typeface="Aptos"/>
               </a:rPr>
-              <a:t>0 / 0</a:t>
+              <a:t>0 / 1</a:t>
             </a:r>
           </a:p>
         </p:txBody>
@@ -5703,7 +5703,7 @@
                 </a:solidFill>
                 <a:latin typeface="Aptos"/>
               </a:rPr>
-              <a:t>FP / FN</a:t>
+              <a:t>20 VAKA FP / FN</a:t>
             </a:r>
           </a:p>
         </p:txBody>
@@ -5797,7 +5797,7 @@
         <p:spPr>
           <a:xfrm>
             <a:off x="2148840" y="3364991"/>
-            <a:ext cx="2223820" cy="164592"/>
+            <a:ext cx="1853183" cy="164592"/>
           </a:xfrm>
           <a:prstGeom prst="rect">
             <a:avLst/>
@@ -6023,7 +6023,7 @@
                 </a:solidFill>
                 <a:latin typeface="Aptos"/>
               </a:rPr>
-              <a:t>25</a:t>
+              <a:t>30</a:t>
             </a:r>
           </a:p>
         </p:txBody>
@@ -6117,7 +6117,7 @@
         <p:spPr>
           <a:xfrm>
             <a:off x="2148840" y="4370832"/>
-            <a:ext cx="2223820" cy="164592"/>
+            <a:ext cx="3938016" cy="164592"/>
           </a:xfrm>
           <a:prstGeom prst="rect">
             <a:avLst/>
@@ -6183,7 +6183,7 @@
                 </a:solidFill>
                 <a:latin typeface="Aptos"/>
               </a:rPr>
-              <a:t>8</a:t>
+              <a:t>17</a:t>
             </a:r>
           </a:p>
         </p:txBody>
@@ -6277,7 +6277,7 @@
         <p:spPr>
           <a:xfrm>
             <a:off x="2148840" y="4873752"/>
-            <a:ext cx="3057753" cy="164592"/>
+            <a:ext cx="4401312" cy="164592"/>
           </a:xfrm>
           <a:prstGeom prst="rect">
             <a:avLst/>
@@ -6343,7 +6343,7 @@
                 </a:solidFill>
                 <a:latin typeface="Aptos"/>
               </a:rPr>
-              <a:t>11</a:t>
+              <a:t>19</a:t>
             </a:r>
           </a:p>
         </p:txBody>
@@ -6378,7 +6378,7 @@
                 </a:solidFill>
                 <a:latin typeface="Aptos"/>
               </a:rPr>
-              <a:t>Architecture</a:t>
+              <a:t>Architecture + KB</a:t>
             </a:r>
           </a:p>
         </p:txBody>
@@ -6437,7 +6437,7 @@
         <p:spPr>
           <a:xfrm>
             <a:off x="2148840" y="5376672"/>
-            <a:ext cx="833932" cy="164592"/>
+            <a:ext cx="1853183" cy="164592"/>
           </a:xfrm>
           <a:prstGeom prst="rect">
             <a:avLst/>
@@ -6503,7 +6503,7 @@
                 </a:solidFill>
                 <a:latin typeface="Aptos"/>
               </a:rPr>
-              <a:t>3</a:t>
+              <a:t>8</a:t>
             </a:r>
           </a:p>
         </p:txBody>
@@ -12834,7 +12834,7 @@
                 </a:solidFill>
                 <a:latin typeface="Aptos"/>
               </a:rPr>
-              <a:t>69/69 + 45/45 + 30/30</a:t>
+              <a:t>82/82 + 45/45 + 30/30</a:t>
             </a:r>
           </a:p>
         </p:txBody>
@@ -12939,7 +12939,7 @@
                 </a:solidFill>
                 <a:latin typeface="Aptos"/>
               </a:rPr>
-              <a:t>codex/evaluation-benchmark  ·  Sürüm 1.2</a:t>
+              <a:t>codex/evaluation-benchmark  ·  Sürüm 1.3</a:t>
             </a:r>
           </a:p>
         </p:txBody>
@@ -13587,7 +13587,7 @@
                 </a:solidFill>
                 <a:latin typeface="Aptos"/>
               </a:rPr>
-              <a:t>67</a:t>
+              <a:t>77</a:t>
             </a:r>
           </a:p>
         </p:txBody>

</xml_diff>

<commit_message>
feat: finalize agentic workflow and durable conversations
</commit_message>
<xml_diff>
--- a/deliverables/CMS-RAG_Nihai_Proje_Sunumu.pptx
+++ b/deliverables/CMS-RAG_Nihai_Proje_Sunumu.pptx
@@ -3906,7 +3906,7 @@
                 </a:solidFill>
                 <a:latin typeface="Aptos"/>
               </a:rPr>
-              <a:t>Sürüm 1.3  ·  06.08.2026  ·  codex/evaluation-benchmark</a:t>
+              <a:t>Sürüm 2.0  ·  18.08.2026  ·  codex/pgvector-lineage · agentic final</a:t>
             </a:r>
           </a:p>
         </p:txBody>
@@ -5194,7 +5194,7 @@
                 </a:solidFill>
                 <a:latin typeface="Aptos"/>
               </a:rPr>
-              <a:t>82 / 82</a:t>
+              <a:t>137 / 137</a:t>
             </a:r>
           </a:p>
         </p:txBody>
@@ -7559,7 +7559,7 @@
                 </a:solidFill>
                 <a:latin typeface="Aptos"/>
               </a:rPr>
-              <a:t>REJECT</a:t>
+              <a:t>HITL</a:t>
             </a:r>
           </a:p>
         </p:txBody>
@@ -7594,7 +7594,7 @@
                 </a:solidFill>
                 <a:latin typeface="Aptos"/>
               </a:rPr>
-              <a:t>Yetersiz kanıtta açık ret</a:t>
+              <a:t>MCP yazmasında operatör onayı</a:t>
             </a:r>
           </a:p>
         </p:txBody>
@@ -10456,9 +10456,9 @@
                 </a:solidFill>
                 <a:latin typeface="Aptos"/>
               </a:rPr>
-              <a:t>Kalıcı vektör deposu
-Kalite eğilim alarmı
-RBAC</a:t>
+              <a:t>RBAC
+Checkpoint saklama politikası
+Kalite eğilim alarmı</a:t>
             </a:r>
           </a:p>
         </p:txBody>
@@ -10655,7 +10655,7 @@
               </a:rPr>
               <a:t>Merkezi audit aktarımı
 Çok modlu retrieval
-Kaynak onay akışı</a:t>
+Kurumsal gözlemlenebilirlik</a:t>
             </a:r>
           </a:p>
         </p:txBody>
@@ -10725,7 +10725,7 @@
                 </a:solidFill>
                 <a:latin typeface="Aptos"/>
               </a:rPr>
-              <a:t>Öncelik: OCR + kalıcı indeks + otomatik regression</a:t>
+              <a:t>Öncelik: CI kalite kapısı + RBAC + kurumsal gözlemlenebilirlik</a:t>
             </a:r>
           </a:p>
         </p:txBody>
@@ -12834,7 +12834,7 @@
                 </a:solidFill>
                 <a:latin typeface="Aptos"/>
               </a:rPr>
-              <a:t>82/82 + 45/45 + 30/30</a:t>
+              <a:t>137/137 + 45/45 + 30/30</a:t>
             </a:r>
           </a:p>
         </p:txBody>
@@ -12939,7 +12939,7 @@
                 </a:solidFill>
                 <a:latin typeface="Aptos"/>
               </a:rPr>
-              <a:t>codex/evaluation-benchmark  ·  Sürüm 1.3</a:t>
+              <a:t>codex/pgvector-lineage · agentic final  ·  Sürüm 2.0</a:t>
             </a:r>
           </a:p>
         </p:txBody>
@@ -13271,7 +13271,7 @@
                 </a:solidFill>
                 <a:latin typeface="Aptos"/>
               </a:rPr>
-              <a:t>41 / 41</a:t>
+              <a:t>137 / 137</a:t>
             </a:r>
           </a:p>
         </p:txBody>
@@ -21000,7 +21000,7 @@
                 </a:solidFill>
                 <a:latin typeface="Aptos"/>
               </a:rPr>
-              <a:t>CMS-RAG  /  KONUŞMA BELLEĞI</a:t>
+              <a:t>CMS-RAG  /  AGENTIC KALICILIK</a:t>
             </a:r>
           </a:p>
         </p:txBody>
@@ -21113,7 +21113,7 @@
                 </a:solidFill>
                 <a:latin typeface="Aptos Display"/>
               </a:rPr>
-              <a:t>Takip sorusu anlaşılır; kapsamlar birbirine sızmaz</a:t>
+              <a:t>Konuşma, kanıt ve bekleyen onay yeniden başlatmada korunur</a:t>
             </a:r>
           </a:p>
         </p:txBody>
@@ -21745,8 +21745,8 @@
         </p:nvSpPr>
         <p:spPr>
           <a:xfrm>
-            <a:off x="2926080" y="5715000"/>
-            <a:ext cx="6309360" cy="320040"/>
+            <a:off x="2148840" y="5715000"/>
+            <a:ext cx="7955279" cy="320040"/>
           </a:xfrm>
           <a:prstGeom prst="rect">
             <a:avLst/>
@@ -21767,7 +21767,7 @@
                 </a:solidFill>
                 <a:latin typeface="Aptos"/>
               </a:rPr>
-              <a:t>En fazla 3 tur · kapsam etiketli · bounded context</a:t>
+              <a:t>PostgreSQL checkpoint · thread geri yükleme · MCP interrupt / resume</a:t>
             </a:r>
           </a:p>
         </p:txBody>

</xml_diff>